<commit_message>
Updated Industry Innovation Lean Business Case
</commit_message>
<xml_diff>
--- a/docs/2_Value_Creation/2a_Product/Industry Innovation/Industry Innovation v1 Lean Business Case.pptx
+++ b/docs/2_Value_Creation/2a_Product/Industry Innovation/Industry Innovation v1 Lean Business Case.pptx
@@ -261,7 +261,7 @@
       <p15:sldGuideLst xmlns:p15="http://schemas.microsoft.com/office/powerpoint/2012/main"/>
     </p:ext>
     <p:ext uri="GoogleSlidesCustomDataVersion2">
-      <go:slidesCustomData xmlns="" xmlns:mc="http://schemas.openxmlformats.org/markup-compatibility/2006" xmlns:mv="urn:schemas-microsoft-com:mac:vml" xmlns:c="http://schemas.openxmlformats.org/drawingml/2006/chart" xmlns:dgm="http://schemas.openxmlformats.org/drawingml/2006/diagram" xmlns:o="urn:schemas-microsoft-com:office:office" xmlns:v="urn:schemas-microsoft-com:vml" xmlns:pvml="urn:schemas-microsoft-com:office:powerpoint" xmlns:com="http://schemas.openxmlformats.org/drawingml/2006/compatibility" xmlns:p14="http://schemas.microsoft.com/office/powerpoint/2010/main" xmlns:p15="http://schemas.microsoft.com/office/powerpoint/2012/main" xmlns:ahyp="http://schemas.microsoft.com/office/drawing/2018/hyperlinkcolor" xmlns:go="http://customooxmlschemas.google.com/" r:id="rId19" roundtripDataSignature="AMtx7mhwEp+Eio5qReXqYqUwMP31HB0A8A=="/>
+      <go:slidesCustomData xmlns:go="http://customooxmlschemas.google.com/" xmlns:ahyp="http://schemas.microsoft.com/office/drawing/2018/hyperlinkcolor" xmlns:p15="http://schemas.microsoft.com/office/powerpoint/2012/main" xmlns:p14="http://schemas.microsoft.com/office/powerpoint/2010/main" xmlns:com="http://schemas.openxmlformats.org/drawingml/2006/compatibility" xmlns:pvml="urn:schemas-microsoft-com:office:powerpoint" xmlns:v="urn:schemas-microsoft-com:vml" xmlns:o="urn:schemas-microsoft-com:office:office" xmlns:dgm="http://schemas.openxmlformats.org/drawingml/2006/diagram" xmlns:c="http://schemas.openxmlformats.org/drawingml/2006/chart" xmlns:mv="urn:schemas-microsoft-com:mac:vml" xmlns:mc="http://schemas.openxmlformats.org/markup-compatibility/2006" xmlns="" r:id="rId19" roundtripDataSignature="AMtx7mhwEp+Eio5qReXqYqUwMP31HB0A8A=="/>
     </p:ext>
   </p:extLst>
 </p:presentation>
@@ -270,7 +270,7 @@
 <file path=ppt/revisionInfo.xml><?xml version="1.0" encoding="utf-8"?>
 <p1510:revInfo xmlns:a="http://schemas.openxmlformats.org/drawingml/2006/main" xmlns:r="http://schemas.openxmlformats.org/officeDocument/2006/relationships" xmlns:p1510="http://schemas.microsoft.com/office/powerpoint/2015/10/main">
   <p1510:revLst>
-    <p1510:client id="{174D3E73-A963-AA40-BB0C-313A56B50F79}" v="43" dt="2024-11-01T20:29:42.206"/>
+    <p1510:client id="{EEBD5E34-3583-7545-A46B-ABA31E2AAE53}" v="2" dt="2026-08-09T19:57:56.318"/>
   </p1510:revLst>
 </p1510:revInfo>
 </file>
@@ -278,67 +278,20 @@
 <file path=ppt/changesInfos/changesInfo1.xml><?xml version="1.0" encoding="utf-8"?>
 <pc:chgInfo xmlns:a="http://schemas.openxmlformats.org/drawingml/2006/main" xmlns:r="http://schemas.openxmlformats.org/officeDocument/2006/relationships" xmlns:ac="http://schemas.microsoft.com/office/drawing/2013/main/command" xmlns:pc="http://schemas.microsoft.com/office/powerpoint/2013/main/command">
   <pc:docChgLst>
-    <pc:chgData name="Rich Reba" userId="8245d172-5b81-40f1-a13b-b71f02cd6700" providerId="ADAL" clId="{C747341F-FAF7-034C-B13E-74ACFD79E63A}"/>
+    <pc:chgData name="Rich Reba" userId="55db41ab6eb3f845" providerId="LiveId" clId="{0E19DA16-244C-5B50-BE0F-52911DD4CA7E}"/>
     <pc:docChg chg="modSld">
-      <pc:chgData name="Rich Reba" userId="8245d172-5b81-40f1-a13b-b71f02cd6700" providerId="ADAL" clId="{C747341F-FAF7-034C-B13E-74ACFD79E63A}" dt="2024-09-05T20:35:10.489" v="65" actId="1076"/>
+      <pc:chgData name="Rich Reba" userId="55db41ab6eb3f845" providerId="LiveId" clId="{0E19DA16-244C-5B50-BE0F-52911DD4CA7E}" dt="2026-08-09T19:57:56.318" v="817"/>
       <pc:docMkLst>
         <pc:docMk/>
       </pc:docMkLst>
       <pc:sldChg chg="modSp mod">
-        <pc:chgData name="Rich Reba" userId="8245d172-5b81-40f1-a13b-b71f02cd6700" providerId="ADAL" clId="{C747341F-FAF7-034C-B13E-74ACFD79E63A}" dt="2024-09-05T20:33:41.742" v="30" actId="14100"/>
+        <pc:chgData name="Rich Reba" userId="55db41ab6eb3f845" providerId="LiveId" clId="{0E19DA16-244C-5B50-BE0F-52911DD4CA7E}" dt="2026-08-09T19:48:54.955" v="43" actId="20577"/>
         <pc:sldMkLst>
           <pc:docMk/>
           <pc:sldMk cId="0" sldId="256"/>
         </pc:sldMkLst>
         <pc:spChg chg="mod">
-          <ac:chgData name="Rich Reba" userId="8245d172-5b81-40f1-a13b-b71f02cd6700" providerId="ADAL" clId="{C747341F-FAF7-034C-B13E-74ACFD79E63A}" dt="2024-09-05T20:33:41.742" v="30" actId="14100"/>
-          <ac:spMkLst>
-            <pc:docMk/>
-            <pc:sldMk cId="0" sldId="256"/>
-            <ac:spMk id="90" creationId="{00000000-0000-0000-0000-000000000000}"/>
-          </ac:spMkLst>
-        </pc:spChg>
-      </pc:sldChg>
-      <pc:sldChg chg="modSp mod">
-        <pc:chgData name="Rich Reba" userId="8245d172-5b81-40f1-a13b-b71f02cd6700" providerId="ADAL" clId="{C747341F-FAF7-034C-B13E-74ACFD79E63A}" dt="2024-09-05T20:35:10.489" v="65" actId="1076"/>
-        <pc:sldMkLst>
-          <pc:docMk/>
-          <pc:sldMk cId="1272635936" sldId="264"/>
-        </pc:sldMkLst>
-        <pc:graphicFrameChg chg="mod modGraphic">
-          <ac:chgData name="Rich Reba" userId="8245d172-5b81-40f1-a13b-b71f02cd6700" providerId="ADAL" clId="{C747341F-FAF7-034C-B13E-74ACFD79E63A}" dt="2024-09-05T20:35:10.489" v="65" actId="1076"/>
-          <ac:graphicFrameMkLst>
-            <pc:docMk/>
-            <pc:sldMk cId="1272635936" sldId="264"/>
-            <ac:graphicFrameMk id="5" creationId="{4B70F3A5-8062-29A2-30D0-2783CB3DFCCA}"/>
-          </ac:graphicFrameMkLst>
-        </pc:graphicFrameChg>
-      </pc:sldChg>
-    </pc:docChg>
-  </pc:docChgLst>
-  <pc:docChgLst>
-    <pc:chgData name="Rich Reba" userId="8245d172-5b81-40f1-a13b-b71f02cd6700" providerId="ADAL" clId="{174D3E73-A963-AA40-BB0C-313A56B50F79}"/>
-    <pc:docChg chg="undo custSel addSld delSld modSld">
-      <pc:chgData name="Rich Reba" userId="8245d172-5b81-40f1-a13b-b71f02cd6700" providerId="ADAL" clId="{174D3E73-A963-AA40-BB0C-313A56B50F79}" dt="2024-11-01T20:30:05.217" v="2140" actId="20577"/>
-      <pc:docMkLst>
-        <pc:docMk/>
-      </pc:docMkLst>
-      <pc:sldChg chg="modSp mod">
-        <pc:chgData name="Rich Reba" userId="8245d172-5b81-40f1-a13b-b71f02cd6700" providerId="ADAL" clId="{174D3E73-A963-AA40-BB0C-313A56B50F79}" dt="2024-11-01T19:32:28.201" v="60" actId="20577"/>
-        <pc:sldMkLst>
-          <pc:docMk/>
-          <pc:sldMk cId="0" sldId="256"/>
-        </pc:sldMkLst>
-        <pc:spChg chg="mod">
-          <ac:chgData name="Rich Reba" userId="8245d172-5b81-40f1-a13b-b71f02cd6700" providerId="ADAL" clId="{174D3E73-A963-AA40-BB0C-313A56B50F79}" dt="2024-11-01T19:32:21.970" v="50" actId="20577"/>
-          <ac:spMkLst>
-            <pc:docMk/>
-            <pc:sldMk cId="0" sldId="256"/>
-            <ac:spMk id="90" creationId="{00000000-0000-0000-0000-000000000000}"/>
-          </ac:spMkLst>
-        </pc:spChg>
-        <pc:spChg chg="mod">
-          <ac:chgData name="Rich Reba" userId="8245d172-5b81-40f1-a13b-b71f02cd6700" providerId="ADAL" clId="{174D3E73-A963-AA40-BB0C-313A56B50F79}" dt="2024-11-01T19:32:28.201" v="60" actId="20577"/>
+          <ac:chgData name="Rich Reba" userId="55db41ab6eb3f845" providerId="LiveId" clId="{0E19DA16-244C-5B50-BE0F-52911DD4CA7E}" dt="2026-08-09T19:48:54.955" v="43" actId="20577"/>
           <ac:spMkLst>
             <pc:docMk/>
             <pc:sldMk cId="0" sldId="256"/>
@@ -347,29 +300,13 @@
         </pc:spChg>
       </pc:sldChg>
       <pc:sldChg chg="modSp mod">
-        <pc:chgData name="Rich Reba" userId="8245d172-5b81-40f1-a13b-b71f02cd6700" providerId="ADAL" clId="{174D3E73-A963-AA40-BB0C-313A56B50F79}" dt="2024-11-01T20:00:28.195" v="972" actId="20577"/>
+        <pc:chgData name="Rich Reba" userId="55db41ab6eb3f845" providerId="LiveId" clId="{0E19DA16-244C-5B50-BE0F-52911DD4CA7E}" dt="2026-08-09T19:52:56.255" v="261" actId="20577"/>
         <pc:sldMkLst>
           <pc:docMk/>
           <pc:sldMk cId="1272635936" sldId="264"/>
         </pc:sldMkLst>
-        <pc:spChg chg="mod">
-          <ac:chgData name="Rich Reba" userId="8245d172-5b81-40f1-a13b-b71f02cd6700" providerId="ADAL" clId="{174D3E73-A963-AA40-BB0C-313A56B50F79}" dt="2024-11-01T19:55:09.076" v="786" actId="1036"/>
-          <ac:spMkLst>
-            <pc:docMk/>
-            <pc:sldMk cId="1272635936" sldId="264"/>
-            <ac:spMk id="6" creationId="{F57F7845-FD8A-DCA4-39DB-1B7D9CF0BA2A}"/>
-          </ac:spMkLst>
-        </pc:spChg>
-        <pc:spChg chg="mod">
-          <ac:chgData name="Rich Reba" userId="8245d172-5b81-40f1-a13b-b71f02cd6700" providerId="ADAL" clId="{174D3E73-A963-AA40-BB0C-313A56B50F79}" dt="2024-11-01T19:32:45.037" v="74" actId="20577"/>
-          <ac:spMkLst>
-            <pc:docMk/>
-            <pc:sldMk cId="1272635936" sldId="264"/>
-            <ac:spMk id="96" creationId="{00000000-0000-0000-0000-000000000000}"/>
-          </ac:spMkLst>
-        </pc:spChg>
-        <pc:graphicFrameChg chg="mod modGraphic">
-          <ac:chgData name="Rich Reba" userId="8245d172-5b81-40f1-a13b-b71f02cd6700" providerId="ADAL" clId="{174D3E73-A963-AA40-BB0C-313A56B50F79}" dt="2024-11-01T20:00:28.195" v="972" actId="20577"/>
+        <pc:graphicFrameChg chg="modGraphic">
+          <ac:chgData name="Rich Reba" userId="55db41ab6eb3f845" providerId="LiveId" clId="{0E19DA16-244C-5B50-BE0F-52911DD4CA7E}" dt="2026-08-09T19:52:56.255" v="261" actId="20577"/>
           <ac:graphicFrameMkLst>
             <pc:docMk/>
             <pc:sldMk cId="1272635936" sldId="264"/>
@@ -377,30 +314,14 @@
           </ac:graphicFrameMkLst>
         </pc:graphicFrameChg>
       </pc:sldChg>
-      <pc:sldChg chg="addSp modSp mod">
-        <pc:chgData name="Rich Reba" userId="8245d172-5b81-40f1-a13b-b71f02cd6700" providerId="ADAL" clId="{174D3E73-A963-AA40-BB0C-313A56B50F79}" dt="2024-11-01T20:07:52.361" v="1316" actId="20577"/>
+      <pc:sldChg chg="modSp mod">
+        <pc:chgData name="Rich Reba" userId="55db41ab6eb3f845" providerId="LiveId" clId="{0E19DA16-244C-5B50-BE0F-52911DD4CA7E}" dt="2026-08-09T19:51:07.765" v="207" actId="20577"/>
         <pc:sldMkLst>
           <pc:docMk/>
           <pc:sldMk cId="4188122143" sldId="266"/>
         </pc:sldMkLst>
-        <pc:spChg chg="mod">
-          <ac:chgData name="Rich Reba" userId="8245d172-5b81-40f1-a13b-b71f02cd6700" providerId="ADAL" clId="{174D3E73-A963-AA40-BB0C-313A56B50F79}" dt="2024-11-01T20:02:38.240" v="1001" actId="1076"/>
-          <ac:spMkLst>
-            <pc:docMk/>
-            <pc:sldMk cId="4188122143" sldId="266"/>
-            <ac:spMk id="5" creationId="{C5748C3E-8A70-958C-B8E4-332FC5861BB3}"/>
-          </ac:spMkLst>
-        </pc:spChg>
-        <pc:spChg chg="add mod">
-          <ac:chgData name="Rich Reba" userId="8245d172-5b81-40f1-a13b-b71f02cd6700" providerId="ADAL" clId="{174D3E73-A963-AA40-BB0C-313A56B50F79}" dt="2024-11-01T20:07:00.143" v="1217" actId="1036"/>
-          <ac:spMkLst>
-            <pc:docMk/>
-            <pc:sldMk cId="4188122143" sldId="266"/>
-            <ac:spMk id="7" creationId="{3BF34AD7-6E8C-6A1C-9085-B5DC5F237EC4}"/>
-          </ac:spMkLst>
-        </pc:spChg>
-        <pc:graphicFrameChg chg="mod modGraphic">
-          <ac:chgData name="Rich Reba" userId="8245d172-5b81-40f1-a13b-b71f02cd6700" providerId="ADAL" clId="{174D3E73-A963-AA40-BB0C-313A56B50F79}" dt="2024-11-01T20:07:52.361" v="1316" actId="20577"/>
+        <pc:graphicFrameChg chg="modGraphic">
+          <ac:chgData name="Rich Reba" userId="55db41ab6eb3f845" providerId="LiveId" clId="{0E19DA16-244C-5B50-BE0F-52911DD4CA7E}" dt="2026-08-09T19:51:07.765" v="207" actId="20577"/>
           <ac:graphicFrameMkLst>
             <pc:docMk/>
             <pc:sldMk cId="4188122143" sldId="266"/>
@@ -409,21 +330,13 @@
         </pc:graphicFrameChg>
       </pc:sldChg>
       <pc:sldChg chg="modSp mod">
-        <pc:chgData name="Rich Reba" userId="8245d172-5b81-40f1-a13b-b71f02cd6700" providerId="ADAL" clId="{174D3E73-A963-AA40-BB0C-313A56B50F79}" dt="2024-11-01T20:27:01.192" v="2027" actId="1036"/>
+        <pc:chgData name="Rich Reba" userId="55db41ab6eb3f845" providerId="LiveId" clId="{0E19DA16-244C-5B50-BE0F-52911DD4CA7E}" dt="2026-08-09T19:53:50.208" v="341" actId="20577"/>
         <pc:sldMkLst>
           <pc:docMk/>
           <pc:sldMk cId="1243007551" sldId="268"/>
         </pc:sldMkLst>
-        <pc:spChg chg="mod">
-          <ac:chgData name="Rich Reba" userId="8245d172-5b81-40f1-a13b-b71f02cd6700" providerId="ADAL" clId="{174D3E73-A963-AA40-BB0C-313A56B50F79}" dt="2024-11-01T20:27:01.192" v="2027" actId="1036"/>
-          <ac:spMkLst>
-            <pc:docMk/>
-            <pc:sldMk cId="1243007551" sldId="268"/>
-            <ac:spMk id="6" creationId="{FC3986F6-425A-0514-DE8E-DE31978EAAD1}"/>
-          </ac:spMkLst>
-        </pc:spChg>
-        <pc:graphicFrameChg chg="mod">
-          <ac:chgData name="Rich Reba" userId="8245d172-5b81-40f1-a13b-b71f02cd6700" providerId="ADAL" clId="{174D3E73-A963-AA40-BB0C-313A56B50F79}" dt="2024-11-01T20:14:26.761" v="1421"/>
+        <pc:graphicFrameChg chg="modGraphic">
+          <ac:chgData name="Rich Reba" userId="55db41ab6eb3f845" providerId="LiveId" clId="{0E19DA16-244C-5B50-BE0F-52911DD4CA7E}" dt="2026-08-09T19:53:50.208" v="341" actId="20577"/>
           <ac:graphicFrameMkLst>
             <pc:docMk/>
             <pc:sldMk cId="1243007551" sldId="268"/>
@@ -431,30 +344,14 @@
           </ac:graphicFrameMkLst>
         </pc:graphicFrameChg>
       </pc:sldChg>
-      <pc:sldChg chg="delSp modSp mod">
-        <pc:chgData name="Rich Reba" userId="8245d172-5b81-40f1-a13b-b71f02cd6700" providerId="ADAL" clId="{174D3E73-A963-AA40-BB0C-313A56B50F79}" dt="2024-11-01T20:26:52.889" v="2013" actId="1036"/>
+      <pc:sldChg chg="modSp mod">
+        <pc:chgData name="Rich Reba" userId="55db41ab6eb3f845" providerId="LiveId" clId="{0E19DA16-244C-5B50-BE0F-52911DD4CA7E}" dt="2026-08-09T19:54:35.048" v="413" actId="20577"/>
         <pc:sldMkLst>
           <pc:docMk/>
           <pc:sldMk cId="450257364" sldId="269"/>
         </pc:sldMkLst>
-        <pc:spChg chg="del">
-          <ac:chgData name="Rich Reba" userId="8245d172-5b81-40f1-a13b-b71f02cd6700" providerId="ADAL" clId="{174D3E73-A963-AA40-BB0C-313A56B50F79}" dt="2024-11-01T20:26:44.677" v="2007" actId="478"/>
-          <ac:spMkLst>
-            <pc:docMk/>
-            <pc:sldMk cId="450257364" sldId="269"/>
-            <ac:spMk id="6" creationId="{7EAC0157-6343-D56D-5D76-3AAA75837A76}"/>
-          </ac:spMkLst>
-        </pc:spChg>
-        <pc:spChg chg="mod">
-          <ac:chgData name="Rich Reba" userId="8245d172-5b81-40f1-a13b-b71f02cd6700" providerId="ADAL" clId="{174D3E73-A963-AA40-BB0C-313A56B50F79}" dt="2024-11-01T20:26:52.889" v="2013" actId="1036"/>
-          <ac:spMkLst>
-            <pc:docMk/>
-            <pc:sldMk cId="450257364" sldId="269"/>
-            <ac:spMk id="7" creationId="{31CA48FC-F211-DAFD-902B-5D682C6B56DD}"/>
-          </ac:spMkLst>
-        </pc:spChg>
-        <pc:graphicFrameChg chg="mod modGraphic">
-          <ac:chgData name="Rich Reba" userId="8245d172-5b81-40f1-a13b-b71f02cd6700" providerId="ADAL" clId="{174D3E73-A963-AA40-BB0C-313A56B50F79}" dt="2024-11-01T20:26:48.762" v="2008" actId="14100"/>
+        <pc:graphicFrameChg chg="modGraphic">
+          <ac:chgData name="Rich Reba" userId="55db41ab6eb3f845" providerId="LiveId" clId="{0E19DA16-244C-5B50-BE0F-52911DD4CA7E}" dt="2026-08-09T19:54:35.048" v="413" actId="20577"/>
           <ac:graphicFrameMkLst>
             <pc:docMk/>
             <pc:sldMk cId="450257364" sldId="269"/>
@@ -462,30 +359,14 @@
           </ac:graphicFrameMkLst>
         </pc:graphicFrameChg>
       </pc:sldChg>
-      <pc:sldChg chg="delSp modSp mod">
-        <pc:chgData name="Rich Reba" userId="8245d172-5b81-40f1-a13b-b71f02cd6700" providerId="ADAL" clId="{174D3E73-A963-AA40-BB0C-313A56B50F79}" dt="2024-11-01T20:26:39.449" v="2006" actId="1076"/>
+      <pc:sldChg chg="modSp mod">
+        <pc:chgData name="Rich Reba" userId="55db41ab6eb3f845" providerId="LiveId" clId="{0E19DA16-244C-5B50-BE0F-52911DD4CA7E}" dt="2026-08-09T19:56:01.815" v="583" actId="20577"/>
         <pc:sldMkLst>
           <pc:docMk/>
           <pc:sldMk cId="4255637138" sldId="270"/>
         </pc:sldMkLst>
-        <pc:spChg chg="del">
-          <ac:chgData name="Rich Reba" userId="8245d172-5b81-40f1-a13b-b71f02cd6700" providerId="ADAL" clId="{174D3E73-A963-AA40-BB0C-313A56B50F79}" dt="2024-11-01T20:26:35.813" v="2005" actId="478"/>
-          <ac:spMkLst>
-            <pc:docMk/>
-            <pc:sldMk cId="4255637138" sldId="270"/>
-            <ac:spMk id="6" creationId="{F2D42400-5633-A72C-1FD7-4E3F59FDFE1F}"/>
-          </ac:spMkLst>
-        </pc:spChg>
-        <pc:spChg chg="mod">
-          <ac:chgData name="Rich Reba" userId="8245d172-5b81-40f1-a13b-b71f02cd6700" providerId="ADAL" clId="{174D3E73-A963-AA40-BB0C-313A56B50F79}" dt="2024-11-01T20:26:39.449" v="2006" actId="1076"/>
-          <ac:spMkLst>
-            <pc:docMk/>
-            <pc:sldMk cId="4255637138" sldId="270"/>
-            <ac:spMk id="7" creationId="{7FE450E7-5500-1557-7587-B39724023C17}"/>
-          </ac:spMkLst>
-        </pc:spChg>
-        <pc:graphicFrameChg chg="mod modGraphic">
-          <ac:chgData name="Rich Reba" userId="8245d172-5b81-40f1-a13b-b71f02cd6700" providerId="ADAL" clId="{174D3E73-A963-AA40-BB0C-313A56B50F79}" dt="2024-11-01T20:26:27.295" v="2004" actId="20577"/>
+        <pc:graphicFrameChg chg="modGraphic">
+          <ac:chgData name="Rich Reba" userId="55db41ab6eb3f845" providerId="LiveId" clId="{0E19DA16-244C-5B50-BE0F-52911DD4CA7E}" dt="2026-08-09T19:56:01.815" v="583" actId="20577"/>
           <ac:graphicFrameMkLst>
             <pc:docMk/>
             <pc:sldMk cId="4255637138" sldId="270"/>
@@ -494,13 +375,13 @@
         </pc:graphicFrameChg>
       </pc:sldChg>
       <pc:sldChg chg="modSp mod">
-        <pc:chgData name="Rich Reba" userId="8245d172-5b81-40f1-a13b-b71f02cd6700" providerId="ADAL" clId="{174D3E73-A963-AA40-BB0C-313A56B50F79}" dt="2024-11-01T20:28:51.082" v="2072" actId="20577"/>
+        <pc:chgData name="Rich Reba" userId="55db41ab6eb3f845" providerId="LiveId" clId="{0E19DA16-244C-5B50-BE0F-52911DD4CA7E}" dt="2026-08-09T19:56:16.672" v="626" actId="20577"/>
         <pc:sldMkLst>
           <pc:docMk/>
           <pc:sldMk cId="67448461" sldId="271"/>
         </pc:sldMkLst>
-        <pc:graphicFrameChg chg="mod modGraphic">
-          <ac:chgData name="Rich Reba" userId="8245d172-5b81-40f1-a13b-b71f02cd6700" providerId="ADAL" clId="{174D3E73-A963-AA40-BB0C-313A56B50F79}" dt="2024-11-01T20:28:51.082" v="2072" actId="20577"/>
+        <pc:graphicFrameChg chg="modGraphic">
+          <ac:chgData name="Rich Reba" userId="55db41ab6eb3f845" providerId="LiveId" clId="{0E19DA16-244C-5B50-BE0F-52911DD4CA7E}" dt="2026-08-09T19:56:16.672" v="626" actId="20577"/>
           <ac:graphicFrameMkLst>
             <pc:docMk/>
             <pc:sldMk cId="67448461" sldId="271"/>
@@ -509,13 +390,13 @@
         </pc:graphicFrameChg>
       </pc:sldChg>
       <pc:sldChg chg="modSp mod">
-        <pc:chgData name="Rich Reba" userId="8245d172-5b81-40f1-a13b-b71f02cd6700" providerId="ADAL" clId="{174D3E73-A963-AA40-BB0C-313A56B50F79}" dt="2024-11-01T20:29:18.545" v="2093"/>
+        <pc:chgData name="Rich Reba" userId="55db41ab6eb3f845" providerId="LiveId" clId="{0E19DA16-244C-5B50-BE0F-52911DD4CA7E}" dt="2026-08-09T19:56:55.372" v="673" actId="20577"/>
         <pc:sldMkLst>
           <pc:docMk/>
           <pc:sldMk cId="3088802820" sldId="272"/>
         </pc:sldMkLst>
-        <pc:graphicFrameChg chg="mod modGraphic">
-          <ac:chgData name="Rich Reba" userId="8245d172-5b81-40f1-a13b-b71f02cd6700" providerId="ADAL" clId="{174D3E73-A963-AA40-BB0C-313A56B50F79}" dt="2024-11-01T20:29:18.545" v="2093"/>
+        <pc:graphicFrameChg chg="modGraphic">
+          <ac:chgData name="Rich Reba" userId="55db41ab6eb3f845" providerId="LiveId" clId="{0E19DA16-244C-5B50-BE0F-52911DD4CA7E}" dt="2026-08-09T19:56:55.372" v="673" actId="20577"/>
           <ac:graphicFrameMkLst>
             <pc:docMk/>
             <pc:sldMk cId="3088802820" sldId="272"/>
@@ -523,91 +404,29 @@
           </ac:graphicFrameMkLst>
         </pc:graphicFrameChg>
       </pc:sldChg>
-      <pc:sldChg chg="modSp del mod">
-        <pc:chgData name="Rich Reba" userId="8245d172-5b81-40f1-a13b-b71f02cd6700" providerId="ADAL" clId="{174D3E73-A963-AA40-BB0C-313A56B50F79}" dt="2024-10-22T01:08:05.414" v="37" actId="2696"/>
-        <pc:sldMkLst>
-          <pc:docMk/>
-          <pc:sldMk cId="3864669982" sldId="274"/>
-        </pc:sldMkLst>
-        <pc:graphicFrameChg chg="modGraphic">
-          <ac:chgData name="Rich Reba" userId="8245d172-5b81-40f1-a13b-b71f02cd6700" providerId="ADAL" clId="{174D3E73-A963-AA40-BB0C-313A56B50F79}" dt="2024-10-22T01:07:06.712" v="31" actId="2161"/>
-          <ac:graphicFrameMkLst>
-            <pc:docMk/>
-            <pc:sldMk cId="3864669982" sldId="274"/>
-            <ac:graphicFrameMk id="5" creationId="{4B70F3A5-8062-29A2-30D0-2783CB3DFCCA}"/>
-          </ac:graphicFrameMkLst>
-        </pc:graphicFrameChg>
-      </pc:sldChg>
-      <pc:sldChg chg="addSp delSp modSp mod">
-        <pc:chgData name="Rich Reba" userId="8245d172-5b81-40f1-a13b-b71f02cd6700" providerId="ADAL" clId="{174D3E73-A963-AA40-BB0C-313A56B50F79}" dt="2024-11-01T20:29:52.420" v="2121" actId="20577"/>
+      <pc:sldChg chg="modSp">
+        <pc:chgData name="Rich Reba" userId="55db41ab6eb3f845" providerId="LiveId" clId="{0E19DA16-244C-5B50-BE0F-52911DD4CA7E}" dt="2026-08-09T19:57:56.318" v="817"/>
         <pc:sldMkLst>
           <pc:docMk/>
           <pc:sldMk cId="2639682451" sldId="275"/>
         </pc:sldMkLst>
-        <pc:spChg chg="mod">
-          <ac:chgData name="Rich Reba" userId="8245d172-5b81-40f1-a13b-b71f02cd6700" providerId="ADAL" clId="{174D3E73-A963-AA40-BB0C-313A56B50F79}" dt="2024-11-01T20:29:38.526" v="2100" actId="20577"/>
-          <ac:spMkLst>
-            <pc:docMk/>
-            <pc:sldMk cId="2639682451" sldId="275"/>
-            <ac:spMk id="96" creationId="{00000000-0000-0000-0000-000000000000}"/>
-          </ac:spMkLst>
-        </pc:spChg>
-        <pc:graphicFrameChg chg="del modGraphic">
-          <ac:chgData name="Rich Reba" userId="8245d172-5b81-40f1-a13b-b71f02cd6700" providerId="ADAL" clId="{174D3E73-A963-AA40-BB0C-313A56B50F79}" dt="2024-10-22T01:08:25.801" v="39" actId="478"/>
-          <ac:graphicFrameMkLst>
-            <pc:docMk/>
-            <pc:sldMk cId="2639682451" sldId="275"/>
-            <ac:graphicFrameMk id="5" creationId="{4B70F3A5-8062-29A2-30D0-2783CB3DFCCA}"/>
-          </ac:graphicFrameMkLst>
-        </pc:graphicFrameChg>
-        <pc:graphicFrameChg chg="add mod modGraphic">
-          <ac:chgData name="Rich Reba" userId="8245d172-5b81-40f1-a13b-b71f02cd6700" providerId="ADAL" clId="{174D3E73-A963-AA40-BB0C-313A56B50F79}" dt="2024-11-01T20:29:52.420" v="2121" actId="20577"/>
+        <pc:graphicFrameChg chg="mod">
+          <ac:chgData name="Rich Reba" userId="55db41ab6eb3f845" providerId="LiveId" clId="{0E19DA16-244C-5B50-BE0F-52911DD4CA7E}" dt="2026-08-09T19:57:56.318" v="817"/>
           <ac:graphicFrameMkLst>
             <pc:docMk/>
             <pc:sldMk cId="2639682451" sldId="275"/>
             <ac:graphicFrameMk id="5" creationId="{4E10C936-0962-5D53-9F05-8487710C36A2}"/>
           </ac:graphicFrameMkLst>
         </pc:graphicFrameChg>
-        <pc:graphicFrameChg chg="add del mod">
-          <ac:chgData name="Rich Reba" userId="8245d172-5b81-40f1-a13b-b71f02cd6700" providerId="ADAL" clId="{174D3E73-A963-AA40-BB0C-313A56B50F79}" dt="2024-11-01T20:29:41.825" v="2101" actId="478"/>
-          <ac:graphicFrameMkLst>
-            <pc:docMk/>
-            <pc:sldMk cId="2639682451" sldId="275"/>
-            <ac:graphicFrameMk id="7" creationId="{99211905-28AA-050E-A1E3-4FEBCC516104}"/>
-          </ac:graphicFrameMkLst>
-        </pc:graphicFrameChg>
       </pc:sldChg>
-      <pc:sldChg chg="del">
-        <pc:chgData name="Rich Reba" userId="8245d172-5b81-40f1-a13b-b71f02cd6700" providerId="ADAL" clId="{174D3E73-A963-AA40-BB0C-313A56B50F79}" dt="2024-11-01T20:08:26.255" v="1318" actId="2696"/>
-        <pc:sldMkLst>
-          <pc:docMk/>
-          <pc:sldMk cId="3191730488" sldId="276"/>
-        </pc:sldMkLst>
-      </pc:sldChg>
-      <pc:sldChg chg="addSp delSp modSp mod">
-        <pc:chgData name="Rich Reba" userId="8245d172-5b81-40f1-a13b-b71f02cd6700" providerId="ADAL" clId="{174D3E73-A963-AA40-BB0C-313A56B50F79}" dt="2024-11-01T20:10:38.626" v="1417"/>
+      <pc:sldChg chg="modSp">
+        <pc:chgData name="Rich Reba" userId="55db41ab6eb3f845" providerId="LiveId" clId="{0E19DA16-244C-5B50-BE0F-52911DD4CA7E}" dt="2026-08-09T19:52:08.065" v="233"/>
         <pc:sldMkLst>
           <pc:docMk/>
           <pc:sldMk cId="368434212" sldId="277"/>
         </pc:sldMkLst>
-        <pc:spChg chg="add mod">
-          <ac:chgData name="Rich Reba" userId="8245d172-5b81-40f1-a13b-b71f02cd6700" providerId="ADAL" clId="{174D3E73-A963-AA40-BB0C-313A56B50F79}" dt="2024-11-01T20:10:38.626" v="1417"/>
-          <ac:spMkLst>
-            <pc:docMk/>
-            <pc:sldMk cId="368434212" sldId="277"/>
-            <ac:spMk id="5" creationId="{798872C2-D47D-A5E4-B7C0-29D65948CD53}"/>
-          </ac:spMkLst>
-        </pc:spChg>
-        <pc:graphicFrameChg chg="del">
-          <ac:chgData name="Rich Reba" userId="8245d172-5b81-40f1-a13b-b71f02cd6700" providerId="ADAL" clId="{174D3E73-A963-AA40-BB0C-313A56B50F79}" dt="2024-11-01T20:10:38.245" v="1416" actId="478"/>
-          <ac:graphicFrameMkLst>
-            <pc:docMk/>
-            <pc:sldMk cId="368434212" sldId="277"/>
-            <ac:graphicFrameMk id="2" creationId="{30929ABE-0A38-27D1-4713-A9783350A181}"/>
-          </ac:graphicFrameMkLst>
-        </pc:graphicFrameChg>
-        <pc:graphicFrameChg chg="add mod">
-          <ac:chgData name="Rich Reba" userId="8245d172-5b81-40f1-a13b-b71f02cd6700" providerId="ADAL" clId="{174D3E73-A963-AA40-BB0C-313A56B50F79}" dt="2024-11-01T20:10:38.626" v="1417"/>
+        <pc:graphicFrameChg chg="mod">
+          <ac:chgData name="Rich Reba" userId="55db41ab6eb3f845" providerId="LiveId" clId="{0E19DA16-244C-5B50-BE0F-52911DD4CA7E}" dt="2026-08-09T19:52:08.065" v="233"/>
           <ac:graphicFrameMkLst>
             <pc:docMk/>
             <pc:sldMk cId="368434212" sldId="277"/>
@@ -615,29 +434,14 @@
           </ac:graphicFrameMkLst>
         </pc:graphicFrameChg>
       </pc:sldChg>
-      <pc:sldChg chg="modSp add del mod">
-        <pc:chgData name="Rich Reba" userId="8245d172-5b81-40f1-a13b-b71f02cd6700" providerId="ADAL" clId="{174D3E73-A963-AA40-BB0C-313A56B50F79}" dt="2024-11-01T20:10:44.193" v="1418" actId="2696"/>
-        <pc:sldMkLst>
-          <pc:docMk/>
-          <pc:sldMk cId="4159369405" sldId="281"/>
-        </pc:sldMkLst>
-        <pc:graphicFrameChg chg="mod modGraphic">
-          <ac:chgData name="Rich Reba" userId="8245d172-5b81-40f1-a13b-b71f02cd6700" providerId="ADAL" clId="{174D3E73-A963-AA40-BB0C-313A56B50F79}" dt="2024-10-22T01:08:01.765" v="36"/>
-          <ac:graphicFrameMkLst>
-            <pc:docMk/>
-            <pc:sldMk cId="4159369405" sldId="281"/>
-            <ac:graphicFrameMk id="5" creationId="{4B70F3A5-8062-29A2-30D0-2783CB3DFCCA}"/>
-          </ac:graphicFrameMkLst>
-        </pc:graphicFrameChg>
-      </pc:sldChg>
-      <pc:sldChg chg="modSp add mod">
-        <pc:chgData name="Rich Reba" userId="8245d172-5b81-40f1-a13b-b71f02cd6700" providerId="ADAL" clId="{174D3E73-A963-AA40-BB0C-313A56B50F79}" dt="2024-11-01T20:10:10.508" v="1415" actId="14734"/>
+      <pc:sldChg chg="modSp mod">
+        <pc:chgData name="Rich Reba" userId="55db41ab6eb3f845" providerId="LiveId" clId="{0E19DA16-244C-5B50-BE0F-52911DD4CA7E}" dt="2026-08-09T19:51:35.135" v="232" actId="20577"/>
         <pc:sldMkLst>
           <pc:docMk/>
           <pc:sldMk cId="3475755944" sldId="282"/>
         </pc:sldMkLst>
-        <pc:graphicFrameChg chg="mod modGraphic">
-          <ac:chgData name="Rich Reba" userId="8245d172-5b81-40f1-a13b-b71f02cd6700" providerId="ADAL" clId="{174D3E73-A963-AA40-BB0C-313A56B50F79}" dt="2024-11-01T20:10:10.508" v="1415" actId="14734"/>
+        <pc:graphicFrameChg chg="modGraphic">
+          <ac:chgData name="Rich Reba" userId="55db41ab6eb3f845" providerId="LiveId" clId="{0E19DA16-244C-5B50-BE0F-52911DD4CA7E}" dt="2026-08-09T19:51:35.135" v="232" actId="20577"/>
           <ac:graphicFrameMkLst>
             <pc:docMk/>
             <pc:sldMk cId="3475755944" sldId="282"/>
@@ -645,14 +449,14 @@
           </ac:graphicFrameMkLst>
         </pc:graphicFrameChg>
       </pc:sldChg>
-      <pc:sldChg chg="modSp add mod">
-        <pc:chgData name="Rich Reba" userId="8245d172-5b81-40f1-a13b-b71f02cd6700" providerId="ADAL" clId="{174D3E73-A963-AA40-BB0C-313A56B50F79}" dt="2024-11-01T20:30:05.217" v="2140" actId="20577"/>
+      <pc:sldChg chg="modSp mod">
+        <pc:chgData name="Rich Reba" userId="55db41ab6eb3f845" providerId="LiveId" clId="{0E19DA16-244C-5B50-BE0F-52911DD4CA7E}" dt="2026-08-09T19:57:44.221" v="816" actId="20577"/>
         <pc:sldMkLst>
           <pc:docMk/>
           <pc:sldMk cId="3960435043" sldId="283"/>
         </pc:sldMkLst>
         <pc:graphicFrameChg chg="modGraphic">
-          <ac:chgData name="Rich Reba" userId="8245d172-5b81-40f1-a13b-b71f02cd6700" providerId="ADAL" clId="{174D3E73-A963-AA40-BB0C-313A56B50F79}" dt="2024-11-01T20:30:05.217" v="2140" actId="20577"/>
+          <ac:chgData name="Rich Reba" userId="55db41ab6eb3f845" providerId="LiveId" clId="{0E19DA16-244C-5B50-BE0F-52911DD4CA7E}" dt="2026-08-09T19:57:44.221" v="816" actId="20577"/>
           <ac:graphicFrameMkLst>
             <pc:docMk/>
             <pc:sldMk cId="3960435043" sldId="283"/>
@@ -16217,7 +16021,7 @@
             </a:pPr>
             <a:r>
               <a:rPr lang="en-US" dirty="0"/>
-              <a:t>Rich Reba, President</a:t>
+              <a:t>Industry Innovation Service Leader</a:t>
             </a:r>
           </a:p>
           <a:p>
@@ -16239,7 +16043,7 @@
             </a:pPr>
             <a:r>
               <a:rPr lang="en-US" dirty="0"/>
-              <a:t>November 1, 2024</a:t>
+              <a:t>August 9, 2026</a:t>
             </a:r>
           </a:p>
         </p:txBody>
@@ -16477,7 +16281,7 @@
           <p:nvPr>
             <p:extLst>
               <p:ext uri="{D42A27DB-BD31-4B8C-83A1-F6EECF244321}">
-                <p14:modId xmlns:p14="http://schemas.microsoft.com/office/powerpoint/2010/main" val="3306982483"/>
+                <p14:modId xmlns:p14="http://schemas.microsoft.com/office/powerpoint/2010/main" val="470827735"/>
               </p:ext>
             </p:extLst>
           </p:nvPr>
@@ -16627,7 +16431,7 @@
                           </a:solidFill>
                           <a:effectLst/>
                         </a:rPr>
-                        <a:t> among sponsored Innovation Teams while harnessing </a:t>
+                        <a:t> among patron-supported Innovation Teams while harnessing </a:t>
                       </a:r>
                       <a:r>
                         <a:rPr lang="en-US" sz="1100" b="1" dirty="0">
@@ -16799,7 +16603,7 @@
                           </a:solidFill>
                           <a:effectLst/>
                         </a:rPr>
-                        <a:t>Demand Generation, Customer Acquisition, and Service Fulfillment for our MVP should be focused on getting leaders in recognizable organizations to sponsor and advocate for industry innovation teams.  As our Service mature beyond MVP, and we find new revenue sources, we will be able to invest in more sophisticated Demand Generation, Customer Acquisition, and Service Fulfillment activities to further accelerate growth and impact.</a:t>
+                        <a:t>Demand Generation, Beneficiaries Engagement, and Delivery of Service for our MVP should be focused on getting leaders in recognizable organizations to become patrons and support industry innovation teams.  As our Service mature beyond MVP, and we find new revenue sources, we will be able to invest in more sophisticated Demand Generation, Beneficiary Engagement, and Delivery of Service activities to further accelerate growth and impact.</a:t>
                       </a:r>
                     </a:p>
                   </a:txBody>
@@ -16922,7 +16726,7 @@
                           </a:solidFill>
                           <a:effectLst/>
                         </a:rPr>
-                        <a:t>An opportunity cost of one 10% fraction of Rich Reba’s time for 2 months, which is equivalent to $10K.</a:t>
+                        <a:t>Estimate: $10K.</a:t>
                       </a:r>
                       <a:endParaRPr lang="en-US" sz="1100" dirty="0">
                         <a:solidFill>
@@ -17118,7 +16922,7 @@
                           <a:ea typeface="MS Mincho" panose="02020609040205080304" pitchFamily="49" charset="-128"/>
                           <a:cs typeface="Arial" panose="020B0604020202020204" pitchFamily="34" charset="0"/>
                         </a:rPr>
-                        <a:t>Lagging indicators:  Increasing benefit to collaborators, sponsors, the Tech Services industry, and humanity, as measured by collaborator and sponsor surveys</a:t>
+                        <a:t>Lagging indicators:  Increasing benefit to subscribers, patrons, the Tech Services industry, and humanity, as measured by subscriber and patron surveys</a:t>
                       </a:r>
                       <a:endParaRPr lang="en-US" sz="1100" dirty="0">
                         <a:solidFill>
@@ -17642,7 +17446,7 @@
           <p:nvPr>
             <p:extLst>
               <p:ext uri="{D42A27DB-BD31-4B8C-83A1-F6EECF244321}">
-                <p14:modId xmlns:p14="http://schemas.microsoft.com/office/powerpoint/2010/main" val="327878258"/>
+                <p14:modId xmlns:p14="http://schemas.microsoft.com/office/powerpoint/2010/main" val="1723319543"/>
               </p:ext>
             </p:extLst>
           </p:nvPr>
@@ -17782,7 +17586,7 @@
                           </a:solidFill>
                           <a:effectLst/>
                         </a:rPr>
-                        <a:t> Service Strategy, Context, Intent, Development Kit, Demand Generation Kit, Customer Acquisition Kit, and Service Fulfillment Kit</a:t>
+                        <a:t> Service Strategy, Context, Intent, Development Kit, Demand Generation Kit, Beneficiaries Engagement Kit, and Delivery of Service Kit</a:t>
                       </a:r>
                       <a:br>
                         <a:rPr lang="en-US" sz="1100" dirty="0">
@@ -18687,7 +18491,7 @@
           <p:nvPr>
             <p:extLst>
               <p:ext uri="{D42A27DB-BD31-4B8C-83A1-F6EECF244321}">
-                <p14:modId xmlns:p14="http://schemas.microsoft.com/office/powerpoint/2010/main" val="2311169602"/>
+                <p14:modId xmlns:p14="http://schemas.microsoft.com/office/powerpoint/2010/main" val="4047730444"/>
               </p:ext>
             </p:extLst>
           </p:nvPr>
@@ -18824,7 +18628,7 @@
                           </a:solidFill>
                           <a:effectLst/>
                         </a:rPr>
-                        <a:t>These include Service Strategy, Context, Intent, Development Kit, Demand Generation Kit, Customer Acquisition Kit, and Service Fulfillment Kit components.</a:t>
+                        <a:t>These include Service Strategy, Context, Intent, Development Kit, Demand Generation Kit, Beneficiaries Engagement Kit, and Delivery of Service Kit components.</a:t>
                       </a:r>
                     </a:p>
                   </a:txBody>
@@ -18923,7 +18727,7 @@
                           </a:solidFill>
                           <a:effectLst/>
                         </a:rPr>
-                        <a:t> produced by the AccelRR8 Consortium Non-Profit</a:t>
+                        <a:t> produced by AccelRR8 LLC</a:t>
                       </a:r>
                     </a:p>
                     <a:p>
@@ -19588,7 +19392,7 @@
           <p:nvPr>
             <p:extLst>
               <p:ext uri="{D42A27DB-BD31-4B8C-83A1-F6EECF244321}">
-                <p14:modId xmlns:p14="http://schemas.microsoft.com/office/powerpoint/2010/main" val="695106209"/>
+                <p14:modId xmlns:p14="http://schemas.microsoft.com/office/powerpoint/2010/main" val="2424982169"/>
               </p:ext>
             </p:extLst>
           </p:nvPr>
@@ -19832,7 +19636,7 @@
                     <a:p>
                       <a:r>
                         <a:rPr lang="en-US" dirty="0"/>
-                        <a:t>&lt;Descriptions of Collateral and Tools used by Demand Generation to engage with potential Customers in market segments about the service&gt;</a:t>
+                        <a:t>&lt;Descriptions of Collateral and Tools used by Demand Generation to engage with potential beneficiaries in market segments about the service&gt;</a:t>
                       </a:r>
                     </a:p>
                   </a:txBody>
@@ -19852,14 +19656,7 @@
                     <a:p>
                       <a:r>
                         <a:rPr lang="en-US" sz="1600" b="0" dirty="0"/>
-                        <a:t>Customer </a:t>
-                      </a:r>
-                      <a:br>
-                        <a:rPr lang="en-US" sz="1600" b="0" dirty="0"/>
-                      </a:br>
-                      <a:r>
-                        <a:rPr lang="en-US" sz="1600" b="0" dirty="0"/>
-                        <a:t>Acquisition Kit</a:t>
+                        <a:t>Beneficiaries Engagement Kit</a:t>
                       </a:r>
                     </a:p>
                   </a:txBody>
@@ -19873,7 +19670,15 @@
                       <a:pPr lvl="2"/>
                       <a:r>
                         <a:rPr lang="en-US" dirty="0"/>
-                        <a:t>&lt;Descriptions of Collateral and Tools used by Customer Acquisition to engage with specific potential Customers about the service&gt;</a:t>
+                        <a:t>&lt;Descriptions of Collateral and Tools used by </a:t>
+                      </a:r>
+                      <a:r>
+                        <a:rPr lang="en-US" dirty="0" err="1"/>
+                        <a:t>Benficiaries</a:t>
+                      </a:r>
+                      <a:r>
+                        <a:rPr lang="en-US" dirty="0"/>
+                        <a:t> Engagement to engage with specific potential beneficiaries about the service&gt;</a:t>
                       </a:r>
                       <a:endParaRPr lang="en-US" sz="1400" b="0" i="0" u="none" strike="noStrike" cap="none" dirty="0">
                         <a:solidFill>
@@ -19903,14 +19708,14 @@
                     <a:p>
                       <a:r>
                         <a:rPr lang="en-US" sz="1600" b="0" dirty="0"/>
-                        <a:t>Service </a:t>
+                        <a:t>Delivery of</a:t>
                       </a:r>
                       <a:br>
                         <a:rPr lang="en-US" sz="1600" b="0" dirty="0"/>
                       </a:br>
                       <a:r>
                         <a:rPr lang="en-US" sz="1600" b="0" dirty="0"/>
-                        <a:t>Fulfillment Kit</a:t>
+                        <a:t>Service Kit</a:t>
                       </a:r>
                     </a:p>
                   </a:txBody>
@@ -19923,7 +19728,7 @@
                     <a:p>
                       <a:r>
                         <a:rPr lang="en-US" dirty="0"/>
-                        <a:t>&lt;Descriptions of Collateral and Tools used by Service Fulfillment to engage with Customers about the service&gt;</a:t>
+                        <a:t>&lt;Descriptions of Collateral and Tools used by Delivery of Service to engage with beneficiaries about the service&gt;</a:t>
                       </a:r>
                     </a:p>
                   </a:txBody>
@@ -21064,7 +20869,7 @@
           <p:nvPr>
             <p:extLst>
               <p:ext uri="{D42A27DB-BD31-4B8C-83A1-F6EECF244321}">
-                <p14:modId xmlns:p14="http://schemas.microsoft.com/office/powerpoint/2010/main" val="2491713440"/>
+                <p14:modId xmlns:p14="http://schemas.microsoft.com/office/powerpoint/2010/main" val="2973619629"/>
               </p:ext>
             </p:extLst>
           </p:nvPr>
@@ -21308,7 +21113,7 @@
                     <a:p>
                       <a:r>
                         <a:rPr lang="en-US" dirty="0"/>
-                        <a:t>&lt;Descriptions of Collateral and Tools used by Demand Generation to engage with potential Customers in market segments about the service&gt;</a:t>
+                        <a:t>&lt;Descriptions of Collateral and Tools used by Demand Generation to engage with potential beneficiaries in market segments about the service&gt;</a:t>
                       </a:r>
                     </a:p>
                   </a:txBody>
@@ -21328,14 +21133,7 @@
                     <a:p>
                       <a:r>
                         <a:rPr lang="en-US" sz="1600" b="0" dirty="0"/>
-                        <a:t>Customer </a:t>
-                      </a:r>
-                      <a:br>
-                        <a:rPr lang="en-US" sz="1600" b="0" dirty="0"/>
-                      </a:br>
-                      <a:r>
-                        <a:rPr lang="en-US" sz="1600" b="0" dirty="0"/>
-                        <a:t>Acquisition Kit</a:t>
+                        <a:t>Beneficiaries Engagement Kit</a:t>
                       </a:r>
                     </a:p>
                   </a:txBody>
@@ -21349,7 +21147,15 @@
                       <a:pPr lvl="2"/>
                       <a:r>
                         <a:rPr lang="en-US" dirty="0"/>
-                        <a:t>&lt;Descriptions of Collateral and Tools used by Customer Acquisition to engage with specific potential Customers about the service&gt;</a:t>
+                        <a:t>&lt;Descriptions of Collateral and Tools used by </a:t>
+                      </a:r>
+                      <a:r>
+                        <a:rPr lang="en-US" dirty="0" err="1"/>
+                        <a:t>Benficiaries</a:t>
+                      </a:r>
+                      <a:r>
+                        <a:rPr lang="en-US" dirty="0"/>
+                        <a:t> Engagement to engage with specific potential beneficiaries about the service&gt;</a:t>
                       </a:r>
                       <a:endParaRPr lang="en-US" sz="1400" b="0" i="0" u="none" strike="noStrike" cap="none" dirty="0">
                         <a:solidFill>
@@ -21379,14 +21185,14 @@
                     <a:p>
                       <a:r>
                         <a:rPr lang="en-US" sz="1600" b="0" dirty="0"/>
-                        <a:t>Service </a:t>
+                        <a:t>Delivery of</a:t>
                       </a:r>
                       <a:br>
                         <a:rPr lang="en-US" sz="1600" b="0" dirty="0"/>
                       </a:br>
                       <a:r>
                         <a:rPr lang="en-US" sz="1600" b="0" dirty="0"/>
-                        <a:t>Fulfillment Kit</a:t>
+                        <a:t>Service Kit</a:t>
                       </a:r>
                     </a:p>
                   </a:txBody>
@@ -21399,7 +21205,7 @@
                     <a:p>
                       <a:r>
                         <a:rPr lang="en-US" dirty="0"/>
-                        <a:t>&lt;Descriptions of Collateral and Tools used by Service Fulfillment to engage with Customers about the service&gt;</a:t>
+                        <a:t>&lt;Descriptions of Collateral and Tools used by Delivery of Service to engage with beneficiaries about the service&gt;</a:t>
                       </a:r>
                     </a:p>
                   </a:txBody>
@@ -21963,7 +21769,7 @@
           <p:nvPr>
             <p:extLst>
               <p:ext uri="{D42A27DB-BD31-4B8C-83A1-F6EECF244321}">
-                <p14:modId xmlns:p14="http://schemas.microsoft.com/office/powerpoint/2010/main" val="233073037"/>
+                <p14:modId xmlns:p14="http://schemas.microsoft.com/office/powerpoint/2010/main" val="808228977"/>
               </p:ext>
             </p:extLst>
           </p:nvPr>
@@ -22100,7 +21906,7 @@
                     <a:p>
                       <a:r>
                         <a:rPr lang="en-US" dirty="0"/>
-                        <a:t>Rich Reba</a:t>
+                        <a:t>Industry Innovation Service Leader</a:t>
                       </a:r>
                     </a:p>
                   </a:txBody>
@@ -22311,7 +22117,7 @@
                           <a:cs typeface="+mn-cs"/>
                           <a:sym typeface="Arial"/>
                         </a:rPr>
-                        <a:t> helps sponsored innovation teams use proven accelerators to develop innovative solutions</a:t>
+                        <a:t> helps patron-supported innovation teams use proven accelerators to develop innovative solutions</a:t>
                       </a:r>
                       <a:r>
                         <a:rPr lang="en-US" dirty="0"/>
@@ -22499,7 +22305,7 @@
                       </a:pPr>
                       <a:r>
                         <a:rPr lang="en-US" b="1" dirty="0"/>
-                        <a:t>Collaborators and Sponsors</a:t>
+                        <a:t>Subscribers and Patrons</a:t>
                       </a:r>
                       <a:r>
                         <a:rPr lang="en-US" dirty="0"/>
@@ -22574,7 +22380,7 @@
                     <a:p>
                       <a:r>
                         <a:rPr lang="en-US" dirty="0"/>
-                        <a:t>1000 collaborators in the network who are net promoters of this service</a:t>
+                        <a:t>1000 subscribers in the network who are net promoters of this service</a:t>
                       </a:r>
                     </a:p>
                   </a:txBody>
@@ -22676,7 +22482,7 @@
                       </a:r>
                       <a:r>
                         <a:rPr lang="en-US" dirty="0"/>
-                        <a:t>  participating in Industry Innovation as a collaborator and/or sponsor must be incredibly easy</a:t>
+                        <a:t>  participating in Industry Innovation as a subscriber and/or patron must be incredibly easy</a:t>
                       </a:r>
                     </a:p>
                   </a:txBody>
@@ -23434,7 +23240,7 @@
           <p:nvPr>
             <p:extLst>
               <p:ext uri="{D42A27DB-BD31-4B8C-83A1-F6EECF244321}">
-                <p14:modId xmlns:p14="http://schemas.microsoft.com/office/powerpoint/2010/main" val="2844381159"/>
+                <p14:modId xmlns:p14="http://schemas.microsoft.com/office/powerpoint/2010/main" val="3112699021"/>
               </p:ext>
             </p:extLst>
           </p:nvPr>
@@ -23868,7 +23674,7 @@
                       </a:pPr>
                       <a:r>
                         <a:rPr lang="en-US" dirty="0"/>
-                        <a:t>       Reduces the risk of this or future delivery?   13:  compounding innovation is needed to attract sponsors</a:t>
+                        <a:t>       Reduces the risk of this or future delivery?   13:  compounding innovation is needed to attract patrons</a:t>
                       </a:r>
                     </a:p>
                     <a:p>
@@ -23893,7 +23699,7 @@
                       </a:pPr>
                       <a:r>
                         <a:rPr lang="en-US" dirty="0"/>
-                        <a:t>       Is there value in the information we receive?  13:  willingness of sponsors and collaborators to engage</a:t>
+                        <a:t>       Is there value in the information we receive?  13:  willingness of patrons and subscribers to engage</a:t>
                       </a:r>
                     </a:p>
                     <a:p>
@@ -23918,7 +23724,7 @@
                       </a:pPr>
                       <a:r>
                         <a:rPr lang="en-US" dirty="0"/>
-                        <a:t>       Enable new business opportunities?  13:  sponsors and collaborators will learn about other Consortium services</a:t>
+                        <a:t>       Enable new business opportunities?  13:  patrons and subscribers will learn about other Consortium services</a:t>
                       </a:r>
                     </a:p>
                     <a:p>
@@ -23990,7 +23796,7 @@
                       </a:pPr>
                       <a:r>
                         <a:rPr lang="en-US" dirty="0"/>
-                        <a:t>      Leaders will need to personally sponsor and develop initial solutions (6 months);</a:t>
+                        <a:t>      Leaders will need to personally become patrons and develop initial solutions (6 months);</a:t>
                       </a:r>
                     </a:p>
                     <a:p>
@@ -24015,7 +23821,7 @@
                       </a:pPr>
                       <a:r>
                         <a:rPr lang="en-US" dirty="0"/>
-                        <a:t>      Leaders will need to engage other Tech Services organization leaders to sponsor innovation (6 months)</a:t>
+                        <a:t>      Leaders will need to engage other Tech Services organization leaders to be patrons for innovation (6 months)</a:t>
                       </a:r>
                     </a:p>
                   </a:txBody>
@@ -24774,7 +24580,7 @@
           <p:nvPr>
             <p:extLst>
               <p:ext uri="{D42A27DB-BD31-4B8C-83A1-F6EECF244321}">
-                <p14:modId xmlns:p14="http://schemas.microsoft.com/office/powerpoint/2010/main" val="560382679"/>
+                <p14:modId xmlns:p14="http://schemas.microsoft.com/office/powerpoint/2010/main" val="3205425362"/>
               </p:ext>
             </p:extLst>
           </p:nvPr>
@@ -24859,7 +24665,7 @@
                           <a:cs typeface="+mn-cs"/>
                           <a:sym typeface="Arial"/>
                         </a:rPr>
-                        <a:t>Sponsoring organizations and individuals can join the AccelRR8 Consortium network as advocates (free advertising, e.g., Bronze Tier)</a:t>
+                        <a:t>Patron organizations and individuals can join the AccelRR8 Consortium network as advocates (free advertising, e.g., Bronze Tier)</a:t>
                       </a:r>
                       <a:endParaRPr lang="en-US" sz="1400" dirty="0">
                         <a:solidFill>
@@ -24955,7 +24761,7 @@
                           </a:solidFill>
                           <a:effectLst/>
                         </a:rPr>
-                        <a:t>Sponsoring organizations and individuals can pay an annual fee and become patrons (e.g., Diamond, Platinum, Gold, Silver) to co-develop exponential solutions for priority industry challenges</a:t>
+                        <a:t>Patron organizations and individuals can pay an annual fee and become higher-level patrons (e.g., Diamond, Platinum, Gold, Silver) to co-develop exponential solutions for priority industry challenges</a:t>
                       </a:r>
                     </a:p>
                   </a:txBody>
@@ -25856,7 +25662,7 @@
           <p:nvPr>
             <p:extLst>
               <p:ext uri="{D42A27DB-BD31-4B8C-83A1-F6EECF244321}">
-                <p14:modId xmlns:p14="http://schemas.microsoft.com/office/powerpoint/2010/main" val="4187023380"/>
+                <p14:modId xmlns:p14="http://schemas.microsoft.com/office/powerpoint/2010/main" val="525542197"/>
               </p:ext>
             </p:extLst>
           </p:nvPr>
@@ -26290,7 +26096,7 @@
                       </a:pPr>
                       <a:r>
                         <a:rPr lang="en-US" dirty="0"/>
-                        <a:t>       Reduces the risk of this or future delivery?   13:  compounding innovation is needed to attract sponsors</a:t>
+                        <a:t>       Reduces the risk of this or future delivery?   13:  compounding innovation is needed to attract patrons</a:t>
                       </a:r>
                     </a:p>
                     <a:p>
@@ -26315,7 +26121,7 @@
                       </a:pPr>
                       <a:r>
                         <a:rPr lang="en-US" dirty="0"/>
-                        <a:t>       Is there value in the information we receive?  13:  willingness of sponsors and collaborators to engage</a:t>
+                        <a:t>       Is there value in the information we receive?  13:  willingness of patrons and subscribers to engage</a:t>
                       </a:r>
                     </a:p>
                     <a:p>
@@ -26340,7 +26146,7 @@
                       </a:pPr>
                       <a:r>
                         <a:rPr lang="en-US" dirty="0"/>
-                        <a:t>       Enable new business opportunities?  13:  sponsors and collaborators will learn about other Consortium services</a:t>
+                        <a:t>       Enable new business opportunities?  13:  patrons and subscribers will learn about other Consortium services</a:t>
                       </a:r>
                     </a:p>
                     <a:p>
@@ -26412,7 +26218,7 @@
                       </a:pPr>
                       <a:r>
                         <a:rPr lang="en-US" dirty="0"/>
-                        <a:t>      Leaders will need to personally sponsor and develop initial solutions (6 months);</a:t>
+                        <a:t>      Leaders will need to personally become patrons and develop initial solutions (6 months);</a:t>
                       </a:r>
                     </a:p>
                     <a:p>
@@ -26437,7 +26243,7 @@
                       </a:pPr>
                       <a:r>
                         <a:rPr lang="en-US" dirty="0"/>
-                        <a:t>      Leaders will need to engage other Tech Services organization leaders to sponsor innovation (6 months)</a:t>
+                        <a:t>      Leaders will need to engage other Tech Services organization leaders to be patrons for innovation (6 months)</a:t>
                       </a:r>
                     </a:p>
                   </a:txBody>
@@ -26593,7 +26399,7 @@
           <p:nvPr>
             <p:extLst>
               <p:ext uri="{D42A27DB-BD31-4B8C-83A1-F6EECF244321}">
-                <p14:modId xmlns:p14="http://schemas.microsoft.com/office/powerpoint/2010/main" val="4291424056"/>
+                <p14:modId xmlns:p14="http://schemas.microsoft.com/office/powerpoint/2010/main" val="284322017"/>
               </p:ext>
             </p:extLst>
           </p:nvPr>
@@ -27041,7 +26847,7 @@
                           <a:cs typeface="+mn-cs"/>
                           <a:sym typeface="Arial"/>
                         </a:rPr>
-                        <a:t>helps sponsored innovation teams use proven accelerators to develop innovative solutions. </a:t>
+                        <a:t>helps patron-supported innovation teams use proven accelerators to develop innovative solutions. </a:t>
                       </a:r>
                       <a:endParaRPr lang="en-US" sz="1100" b="1" i="0" u="none" strike="noStrike" cap="none" dirty="0">
                         <a:solidFill>
@@ -27331,7 +27137,7 @@
                           </a:solidFill>
                           <a:effectLst/>
                         </a:rPr>
-                        <a:t>Collaborators and Sponsors: </a:t>
+                        <a:t>Subscribers and Patrons: </a:t>
                       </a:r>
                       <a:r>
                         <a:rPr lang="en-US" sz="1100" dirty="0">
@@ -27366,7 +27172,7 @@
                           </a:solidFill>
                           <a:effectLst/>
                         </a:rPr>
-                        <a:t>cross-company learning among leaders with scarce talents as measured via survey of collaborators</a:t>
+                        <a:t>cross-company learning among leaders with scarce talents as measured via survey of subscribers</a:t>
                       </a:r>
                       <a:br>
                         <a:rPr lang="en-US" sz="1100" dirty="0">
@@ -27410,7 +27216,7 @@
                           </a:solidFill>
                           <a:effectLst/>
                         </a:rPr>
-                        <a:t>) as measured via survey of collaborators</a:t>
+                        <a:t>) as measured via survey of subscribers</a:t>
                       </a:r>
                     </a:p>
                   </a:txBody>
@@ -27471,7 +27277,7 @@
                           </a:solidFill>
                           <a:effectLst/>
                         </a:rPr>
-                        <a:t>1000 collaborators </a:t>
+                        <a:t>1000 subscribers </a:t>
                       </a:r>
                       <a:br>
                         <a:rPr lang="en-US" sz="1100" dirty="0">
@@ -27522,7 +27328,7 @@
                           </a:solidFill>
                           <a:effectLst/>
                         </a:rPr>
-                        <a:t>- are Net Promoters as measured via survey of collaborators.</a:t>
+                        <a:t>- are Net Promoters as measured via survey of subscribers.</a:t>
                       </a:r>
                       <a:endParaRPr lang="en-US" sz="1100" dirty="0">
                         <a:solidFill>
@@ -28047,7 +27853,7 @@
           <p:nvPr>
             <p:extLst>
               <p:ext uri="{D42A27DB-BD31-4B8C-83A1-F6EECF244321}">
-                <p14:modId xmlns:p14="http://schemas.microsoft.com/office/powerpoint/2010/main" val="1008077092"/>
+                <p14:modId xmlns:p14="http://schemas.microsoft.com/office/powerpoint/2010/main" val="1400341906"/>
               </p:ext>
             </p:extLst>
           </p:nvPr>
@@ -28136,7 +27942,7 @@
                           <a:cs typeface="+mn-cs"/>
                           <a:sym typeface="Arial"/>
                         </a:rPr>
-                        <a:t>Sponsoring organizations and individuals can join the AccelRR8 Consortium network as advocates (free advertising, e.g., Bronze Tier)</a:t>
+                        <a:t>Patron organizations and individuals can join the AccelRR8 Consortium network as advocates (free advertising, e.g., Bronze Tier)</a:t>
                       </a:r>
                       <a:endParaRPr lang="en-US" sz="1100" dirty="0">
                         <a:solidFill>
@@ -28196,7 +28002,7 @@
                           </a:solidFill>
                           <a:effectLst/>
                         </a:rPr>
-                        <a:t>Sponsoring organizations and individuals can pay an annual fee and become patrons (e.g., Diamond, Platinum, Gold, Silver) to co-develop exponential solutions for priority industry challenges</a:t>
+                        <a:t>Patron organizations and individuals can pay an annual fee and become higher-level patrons (e.g., Diamond, Platinum, Gold, Silver) to co-develop exponential solutions for priority industry challenges</a:t>
                       </a:r>
                     </a:p>
                   </a:txBody>
@@ -28441,7 +28247,7 @@
                       </a:r>
                       <a:r>
                         <a:rPr lang="en-US" sz="1100" dirty="0"/>
-                        <a:t>participating in Industry Innovation as a collaborator and/or sponsor must be incredibly easy</a:t>
+                        <a:t>participating in Industry Innovation as a subscriber and/or patron must be incredibly easy</a:t>
                       </a:r>
                       <a:r>
                         <a:rPr lang="en-US" sz="1100" dirty="0">
@@ -28539,7 +28345,7 @@
                           </a:solidFill>
                           <a:effectLst/>
                         </a:rPr>
-                        <a:t>Sponsoring organizations and individuals simply click to identify as an advocate for an innovation team in the AccelRR8 Consortium’s free electronic platform</a:t>
+                        <a:t>Patron organizations and individuals simply click to identify as an advocate for an innovation team in the AccelRR8 Consortium’s free electronic platform</a:t>
                       </a:r>
                     </a:p>
                     <a:p>
@@ -28564,7 +28370,7 @@
                           </a:solidFill>
                           <a:effectLst/>
                         </a:rPr>
-                        <a:t>Collaborators simply click to join sponsored innovation teams </a:t>
+                        <a:t>Subscribers simply click to join sponsored innovation teams </a:t>
                       </a:r>
                       <a:endParaRPr lang="en-US" sz="1100" dirty="0">
                         <a:solidFill>
@@ -28761,7 +28567,7 @@
                           </a:solidFill>
                           <a:effectLst/>
                         </a:rPr>
-                        <a:t>MVP desirability, viability, feasibility, and sustainability were verified by the Board of Directors as well as a subset of Advisors and Initial Collaborators.</a:t>
+                        <a:t>MVP desirability, viability, feasibility, and sustainability were verified by the Board of Directors as well as a subset of Advisors and Initial Subscribers.</a:t>
                       </a:r>
                       <a:endParaRPr lang="en-US" sz="1100" b="0" i="0" u="none" strike="noStrike" cap="none" dirty="0">
                         <a:solidFill>

</xml_diff>

<commit_message>
Updated Industry Innovation Service Lean Business Case
</commit_message>
<xml_diff>
--- a/docs/2_Value_Creation/2a_Product/Industry Innovation/Industry Innovation v1 Lean Business Case.pptx
+++ b/docs/2_Value_Creation/2a_Product/Industry Innovation/Industry Innovation v1 Lean Business Case.pptx
@@ -261,7 +261,7 @@
       <p15:sldGuideLst xmlns:p15="http://schemas.microsoft.com/office/powerpoint/2012/main"/>
     </p:ext>
     <p:ext uri="GoogleSlidesCustomDataVersion2">
-      <go:slidesCustomData xmlns:go="http://customooxmlschemas.google.com/" xmlns:ahyp="http://schemas.microsoft.com/office/drawing/2018/hyperlinkcolor" xmlns:p15="http://schemas.microsoft.com/office/powerpoint/2012/main" xmlns:p14="http://schemas.microsoft.com/office/powerpoint/2010/main" xmlns:com="http://schemas.openxmlformats.org/drawingml/2006/compatibility" xmlns:pvml="urn:schemas-microsoft-com:office:powerpoint" xmlns:v="urn:schemas-microsoft-com:vml" xmlns:o="urn:schemas-microsoft-com:office:office" xmlns:dgm="http://schemas.openxmlformats.org/drawingml/2006/diagram" xmlns:c="http://schemas.openxmlformats.org/drawingml/2006/chart" xmlns:mv="urn:schemas-microsoft-com:mac:vml" xmlns:mc="http://schemas.openxmlformats.org/markup-compatibility/2006" xmlns="" r:id="rId19" roundtripDataSignature="AMtx7mhwEp+Eio5qReXqYqUwMP31HB0A8A=="/>
+      <go:slidesCustomData xmlns="" xmlns:mc="http://schemas.openxmlformats.org/markup-compatibility/2006" xmlns:mv="urn:schemas-microsoft-com:mac:vml" xmlns:c="http://schemas.openxmlformats.org/drawingml/2006/chart" xmlns:dgm="http://schemas.openxmlformats.org/drawingml/2006/diagram" xmlns:o="urn:schemas-microsoft-com:office:office" xmlns:v="urn:schemas-microsoft-com:vml" xmlns:pvml="urn:schemas-microsoft-com:office:powerpoint" xmlns:com="http://schemas.openxmlformats.org/drawingml/2006/compatibility" xmlns:p14="http://schemas.microsoft.com/office/powerpoint/2010/main" xmlns:p15="http://schemas.microsoft.com/office/powerpoint/2012/main" xmlns:ahyp="http://schemas.microsoft.com/office/drawing/2018/hyperlinkcolor" xmlns:go="http://customooxmlschemas.google.com/" r:id="rId19" roundtripDataSignature="AMtx7mhwEp+Eio5qReXqYqUwMP31HB0A8A=="/>
     </p:ext>
   </p:extLst>
 </p:presentation>
@@ -280,7 +280,7 @@
   <pc:docChgLst>
     <pc:chgData name="Rich Reba" userId="55db41ab6eb3f845" providerId="LiveId" clId="{0E19DA16-244C-5B50-BE0F-52911DD4CA7E}"/>
     <pc:docChg chg="modSld">
-      <pc:chgData name="Rich Reba" userId="55db41ab6eb3f845" providerId="LiveId" clId="{0E19DA16-244C-5B50-BE0F-52911DD4CA7E}" dt="2026-08-09T19:57:56.318" v="817"/>
+      <pc:chgData name="Rich Reba" userId="55db41ab6eb3f845" providerId="LiveId" clId="{0E19DA16-244C-5B50-BE0F-52911DD4CA7E}" dt="2026-08-09T19:59:58.427" v="865" actId="20577"/>
       <pc:docMkLst>
         <pc:docMk/>
       </pc:docMkLst>
@@ -330,13 +330,13 @@
         </pc:graphicFrameChg>
       </pc:sldChg>
       <pc:sldChg chg="modSp mod">
-        <pc:chgData name="Rich Reba" userId="55db41ab6eb3f845" providerId="LiveId" clId="{0E19DA16-244C-5B50-BE0F-52911DD4CA7E}" dt="2026-08-09T19:53:50.208" v="341" actId="20577"/>
+        <pc:chgData name="Rich Reba" userId="55db41ab6eb3f845" providerId="LiveId" clId="{0E19DA16-244C-5B50-BE0F-52911DD4CA7E}" dt="2026-08-09T19:59:58.427" v="865" actId="20577"/>
         <pc:sldMkLst>
           <pc:docMk/>
           <pc:sldMk cId="1243007551" sldId="268"/>
         </pc:sldMkLst>
         <pc:graphicFrameChg chg="modGraphic">
-          <ac:chgData name="Rich Reba" userId="55db41ab6eb3f845" providerId="LiveId" clId="{0E19DA16-244C-5B50-BE0F-52911DD4CA7E}" dt="2026-08-09T19:53:50.208" v="341" actId="20577"/>
+          <ac:chgData name="Rich Reba" userId="55db41ab6eb3f845" providerId="LiveId" clId="{0E19DA16-244C-5B50-BE0F-52911DD4CA7E}" dt="2026-08-09T19:59:58.427" v="865" actId="20577"/>
           <ac:graphicFrameMkLst>
             <pc:docMk/>
             <pc:sldMk cId="1243007551" sldId="268"/>
@@ -26399,7 +26399,7 @@
           <p:nvPr>
             <p:extLst>
               <p:ext uri="{D42A27DB-BD31-4B8C-83A1-F6EECF244321}">
-                <p14:modId xmlns:p14="http://schemas.microsoft.com/office/powerpoint/2010/main" val="284322017"/>
+                <p14:modId xmlns:p14="http://schemas.microsoft.com/office/powerpoint/2010/main" val="60650120"/>
               </p:ext>
             </p:extLst>
           </p:nvPr>
@@ -26541,7 +26541,7 @@
                           </a:solidFill>
                           <a:effectLst/>
                         </a:rPr>
-                        <a:t>Rich Reba</a:t>
+                        <a:t>Industry Innovation Service Leader</a:t>
                       </a:r>
                     </a:p>
                   </a:txBody>
@@ -26602,34 +26602,7 @@
                           </a:solidFill>
                           <a:effectLst/>
                         </a:rPr>
-                        <a:t>Core Boosters:  Board Members, Sumo </a:t>
-                      </a:r>
-                      <a:r>
-                        <a:rPr lang="en-US" sz="1100" dirty="0" err="1">
-                          <a:solidFill>
-                            <a:schemeClr val="tx1"/>
-                          </a:solidFill>
-                          <a:effectLst/>
-                        </a:rPr>
-                        <a:t>Mitro</a:t>
-                      </a:r>
-                      <a:r>
-                        <a:rPr lang="en-US" sz="1100" dirty="0">
-                          <a:solidFill>
-                            <a:schemeClr val="tx1"/>
-                          </a:solidFill>
-                          <a:effectLst/>
-                        </a:rPr>
-                        <a:t>, Pete </a:t>
-                      </a:r>
-                      <a:r>
-                        <a:rPr lang="en-US" sz="1100" dirty="0" err="1">
-                          <a:solidFill>
-                            <a:schemeClr val="tx1"/>
-                          </a:solidFill>
-                          <a:effectLst/>
-                        </a:rPr>
-                        <a:t>Tseronis</a:t>
+                        <a:t>Core Boosters:  Board Members, Board Advisors</a:t>
                       </a:r>
                       <a:endParaRPr lang="en-US" sz="1100" dirty="0">
                         <a:solidFill>

</xml_diff>